<commit_message>
Add presentation speaker script (Word) and embed notes into PPT slides
Co-Authored-By: Claude Opus 4.8 <noreply@anthropic.com>
Claude-Session: https://claude.ai/code/session_01HpG4fuxJt81pgqzdecA2Va
</commit_message>
<xml_diff>
--- a/isaac-sim-study/VPK_PhysicalAI_PoC_발표자료.pptx
+++ b/isaac-sim-study/VPK_PhysicalAI_PoC_발표자료.pptx
@@ -113,6 +113,986 @@
     </a:lvl9pPr>
   </p:defaultTextStyle>
 </p:presentation>
+</file>
+
+<file path=ppt/notesMasters/notesMaster1.xml><?xml version="1.0" encoding="utf-8"?>
+<p:notesMaster xmlns:a="http://schemas.openxmlformats.org/drawingml/2006/main" xmlns:p="http://schemas.openxmlformats.org/presentationml/2006/main" xmlns:r="http://schemas.openxmlformats.org/officeDocument/2006/relationships">
+  <p:cSld>
+    <p:bg>
+      <p:bgRef idx="1001">
+        <a:schemeClr val="bg1"/>
+      </p:bgRef>
+    </p:bg>
+    <p:spTree>
+      <p:nvGrpSpPr>
+        <p:cNvPr id="1" name=""/>
+        <p:cNvGrpSpPr/>
+        <p:nvPr/>
+      </p:nvGrpSpPr>
+      <p:grpSpPr>
+        <a:xfrm>
+          <a:off x="0" y="0"/>
+          <a:ext cx="0" cy="0"/>
+          <a:chOff x="0" y="0"/>
+          <a:chExt cx="0" cy="0"/>
+        </a:xfrm>
+      </p:grpSpPr>
+      <p:sp>
+        <p:nvSpPr>
+          <p:cNvPr id="2" name="Header Placeholder 1"/>
+          <p:cNvSpPr>
+            <a:spLocks noGrp="1"/>
+          </p:cNvSpPr>
+          <p:nvPr>
+            <p:ph type="hdr" sz="quarter"/>
+          </p:nvPr>
+        </p:nvSpPr>
+        <p:spPr>
+          <a:xfrm>
+            <a:off x="0" y="0"/>
+            <a:ext cx="2971800" cy="457200"/>
+          </a:xfrm>
+          <a:prstGeom prst="rect">
+            <a:avLst/>
+          </a:prstGeom>
+        </p:spPr>
+        <p:txBody>
+          <a:bodyPr vert="horz" lIns="91440" tIns="45720" rIns="91440" bIns="45720" rtlCol="0"/>
+          <a:lstStyle>
+            <a:lvl1pPr algn="l">
+              <a:defRPr sz="1200"/>
+            </a:lvl1pPr>
+          </a:lstStyle>
+          <a:p>
+            <a:endParaRPr lang="en-US"/>
+          </a:p>
+        </p:txBody>
+      </p:sp>
+      <p:sp>
+        <p:nvSpPr>
+          <p:cNvPr id="3" name="Date Placeholder 2"/>
+          <p:cNvSpPr>
+            <a:spLocks noGrp="1"/>
+          </p:cNvSpPr>
+          <p:nvPr>
+            <p:ph type="dt" idx="1"/>
+          </p:nvPr>
+        </p:nvSpPr>
+        <p:spPr>
+          <a:xfrm>
+            <a:off x="3884613" y="0"/>
+            <a:ext cx="2971800" cy="457200"/>
+          </a:xfrm>
+          <a:prstGeom prst="rect">
+            <a:avLst/>
+          </a:prstGeom>
+        </p:spPr>
+        <p:txBody>
+          <a:bodyPr vert="horz" lIns="91440" tIns="45720" rIns="91440" bIns="45720" rtlCol="0"/>
+          <a:lstStyle>
+            <a:lvl1pPr algn="r">
+              <a:defRPr sz="1200"/>
+            </a:lvl1pPr>
+          </a:lstStyle>
+          <a:p>
+            <a:fld id="{0F89C1C7-3DCD-1040-A9CF-14679D8B5DDD}" type="datetimeFigureOut">
+              <a:rPr lang="en-US" smtClean="0"/>
+              <a:t>10/17/16</a:t>
+            </a:fld>
+            <a:endParaRPr lang="en-US"/>
+          </a:p>
+        </p:txBody>
+      </p:sp>
+      <p:sp>
+        <p:nvSpPr>
+          <p:cNvPr id="4" name="Slide Image Placeholder 3"/>
+          <p:cNvSpPr>
+            <a:spLocks noGrp="1" noRot="1" noChangeAspect="1"/>
+          </p:cNvSpPr>
+          <p:nvPr>
+            <p:ph type="sldImg" idx="2"/>
+          </p:nvPr>
+        </p:nvSpPr>
+        <p:spPr>
+          <a:xfrm>
+            <a:off x="1143000" y="685800"/>
+            <a:ext cx="4572000" cy="3429000"/>
+          </a:xfrm>
+          <a:prstGeom prst="rect">
+            <a:avLst/>
+          </a:prstGeom>
+          <a:noFill/>
+          <a:ln w="12700">
+            <a:solidFill>
+              <a:prstClr val="black"/>
+            </a:solidFill>
+          </a:ln>
+        </p:spPr>
+        <p:txBody>
+          <a:bodyPr vert="horz" lIns="91440" tIns="45720" rIns="91440" bIns="45720" rtlCol="0" anchor="ctr"/>
+          <a:lstStyle/>
+          <a:p>
+            <a:endParaRPr lang="en-US"/>
+          </a:p>
+        </p:txBody>
+      </p:sp>
+      <p:sp>
+        <p:nvSpPr>
+          <p:cNvPr id="5" name="Notes Placeholder 4"/>
+          <p:cNvSpPr>
+            <a:spLocks noGrp="1"/>
+          </p:cNvSpPr>
+          <p:nvPr>
+            <p:ph type="body" sz="quarter" idx="3"/>
+          </p:nvPr>
+        </p:nvSpPr>
+        <p:spPr>
+          <a:xfrm>
+            <a:off x="685800" y="4343400"/>
+            <a:ext cx="5486400" cy="4114800"/>
+          </a:xfrm>
+          <a:prstGeom prst="rect">
+            <a:avLst/>
+          </a:prstGeom>
+        </p:spPr>
+        <p:txBody>
+          <a:bodyPr vert="horz" lIns="91440" tIns="45720" rIns="91440" bIns="45720" rtlCol="0"/>
+          <a:lstStyle/>
+          <a:p>
+            <a:pPr lvl="0"/>
+            <a:r>
+              <a:rPr lang="en-US" smtClean="0"/>
+              <a:t>Click to edit Master text styles</a:t>
+            </a:r>
+          </a:p>
+          <a:p>
+            <a:pPr lvl="1"/>
+            <a:r>
+              <a:rPr lang="en-US" smtClean="0"/>
+              <a:t>Second level</a:t>
+            </a:r>
+          </a:p>
+          <a:p>
+            <a:pPr lvl="2"/>
+            <a:r>
+              <a:rPr lang="en-US" smtClean="0"/>
+              <a:t>Third level</a:t>
+            </a:r>
+          </a:p>
+          <a:p>
+            <a:pPr lvl="3"/>
+            <a:r>
+              <a:rPr lang="en-US" smtClean="0"/>
+              <a:t>Fourth level</a:t>
+            </a:r>
+          </a:p>
+          <a:p>
+            <a:pPr lvl="4"/>
+            <a:r>
+              <a:rPr lang="en-US" smtClean="0"/>
+              <a:t>Fifth level</a:t>
+            </a:r>
+            <a:endParaRPr lang="en-US"/>
+          </a:p>
+        </p:txBody>
+      </p:sp>
+      <p:sp>
+        <p:nvSpPr>
+          <p:cNvPr id="6" name="Footer Placeholder 5"/>
+          <p:cNvSpPr>
+            <a:spLocks noGrp="1"/>
+          </p:cNvSpPr>
+          <p:nvPr>
+            <p:ph type="ftr" sz="quarter" idx="4"/>
+          </p:nvPr>
+        </p:nvSpPr>
+        <p:spPr>
+          <a:xfrm>
+            <a:off x="0" y="8685213"/>
+            <a:ext cx="2971800" cy="457200"/>
+          </a:xfrm>
+          <a:prstGeom prst="rect">
+            <a:avLst/>
+          </a:prstGeom>
+        </p:spPr>
+        <p:txBody>
+          <a:bodyPr vert="horz" lIns="91440" tIns="45720" rIns="91440" bIns="45720" rtlCol="0" anchor="b"/>
+          <a:lstStyle>
+            <a:lvl1pPr algn="l">
+              <a:defRPr sz="1200"/>
+            </a:lvl1pPr>
+          </a:lstStyle>
+          <a:p>
+            <a:endParaRPr lang="en-US"/>
+          </a:p>
+        </p:txBody>
+      </p:sp>
+      <p:sp>
+        <p:nvSpPr>
+          <p:cNvPr id="7" name="Slide Number Placeholder 6"/>
+          <p:cNvSpPr>
+            <a:spLocks noGrp="1"/>
+          </p:cNvSpPr>
+          <p:nvPr>
+            <p:ph type="sldNum" sz="quarter" idx="5"/>
+          </p:nvPr>
+        </p:nvSpPr>
+        <p:spPr>
+          <a:xfrm>
+            <a:off x="3884613" y="8685213"/>
+            <a:ext cx="2971800" cy="457200"/>
+          </a:xfrm>
+          <a:prstGeom prst="rect">
+            <a:avLst/>
+          </a:prstGeom>
+        </p:spPr>
+        <p:txBody>
+          <a:bodyPr vert="horz" lIns="91440" tIns="45720" rIns="91440" bIns="45720" rtlCol="0" anchor="b"/>
+          <a:lstStyle>
+            <a:lvl1pPr algn="r">
+              <a:defRPr sz="1200"/>
+            </a:lvl1pPr>
+          </a:lstStyle>
+          <a:p>
+            <a:fld id="{BB5E49A5-4136-284D-997B-48E1D791AD67}" type="slidenum">
+              <a:rPr lang="en-US" smtClean="0"/>
+              <a:t>‹#›</a:t>
+            </a:fld>
+            <a:endParaRPr lang="en-US"/>
+          </a:p>
+        </p:txBody>
+      </p:sp>
+    </p:spTree>
+    <p:extLst>
+      <p:ext uri="{BB962C8B-B14F-4D97-AF65-F5344CB8AC3E}">
+        <p14:creationId xmlns:p14="http://schemas.microsoft.com/office/powerpoint/2010/main" val="2623252185"/>
+      </p:ext>
+    </p:extLst>
+  </p:cSld>
+  <p:clrMap bg1="lt1" tx1="dk1" bg2="lt2" tx2="dk2" accent1="accent1" accent2="accent2" accent3="accent3" accent4="accent4" accent5="accent5" accent6="accent6" hlink="hlink" folHlink="folHlink"/>
+  <p:notesStyle>
+    <a:lvl1pPr marL="0" algn="l" defTabSz="457200" rtl="0" eaLnBrk="1" latinLnBrk="0" hangingPunct="1">
+      <a:defRPr sz="1200" kern="1200">
+        <a:solidFill>
+          <a:schemeClr val="tx1"/>
+        </a:solidFill>
+        <a:latin typeface="+mn-lt"/>
+        <a:ea typeface="+mn-ea"/>
+        <a:cs typeface="+mn-cs"/>
+      </a:defRPr>
+    </a:lvl1pPr>
+    <a:lvl2pPr marL="457200" algn="l" defTabSz="457200" rtl="0" eaLnBrk="1" latinLnBrk="0" hangingPunct="1">
+      <a:defRPr sz="1200" kern="1200">
+        <a:solidFill>
+          <a:schemeClr val="tx1"/>
+        </a:solidFill>
+        <a:latin typeface="+mn-lt"/>
+        <a:ea typeface="+mn-ea"/>
+        <a:cs typeface="+mn-cs"/>
+      </a:defRPr>
+    </a:lvl2pPr>
+    <a:lvl3pPr marL="914400" algn="l" defTabSz="457200" rtl="0" eaLnBrk="1" latinLnBrk="0" hangingPunct="1">
+      <a:defRPr sz="1200" kern="1200">
+        <a:solidFill>
+          <a:schemeClr val="tx1"/>
+        </a:solidFill>
+        <a:latin typeface="+mn-lt"/>
+        <a:ea typeface="+mn-ea"/>
+        <a:cs typeface="+mn-cs"/>
+      </a:defRPr>
+    </a:lvl3pPr>
+    <a:lvl4pPr marL="1371600" algn="l" defTabSz="457200" rtl="0" eaLnBrk="1" latinLnBrk="0" hangingPunct="1">
+      <a:defRPr sz="1200" kern="1200">
+        <a:solidFill>
+          <a:schemeClr val="tx1"/>
+        </a:solidFill>
+        <a:latin typeface="+mn-lt"/>
+        <a:ea typeface="+mn-ea"/>
+        <a:cs typeface="+mn-cs"/>
+      </a:defRPr>
+    </a:lvl4pPr>
+    <a:lvl5pPr marL="1828800" algn="l" defTabSz="457200" rtl="0" eaLnBrk="1" latinLnBrk="0" hangingPunct="1">
+      <a:defRPr sz="1200" kern="1200">
+        <a:solidFill>
+          <a:schemeClr val="tx1"/>
+        </a:solidFill>
+        <a:latin typeface="+mn-lt"/>
+        <a:ea typeface="+mn-ea"/>
+        <a:cs typeface="+mn-cs"/>
+      </a:defRPr>
+    </a:lvl5pPr>
+    <a:lvl6pPr marL="2286000" algn="l" defTabSz="457200" rtl="0" eaLnBrk="1" latinLnBrk="0" hangingPunct="1">
+      <a:defRPr sz="1200" kern="1200">
+        <a:solidFill>
+          <a:schemeClr val="tx1"/>
+        </a:solidFill>
+        <a:latin typeface="+mn-lt"/>
+        <a:ea typeface="+mn-ea"/>
+        <a:cs typeface="+mn-cs"/>
+      </a:defRPr>
+    </a:lvl6pPr>
+    <a:lvl7pPr marL="2743200" algn="l" defTabSz="457200" rtl="0" eaLnBrk="1" latinLnBrk="0" hangingPunct="1">
+      <a:defRPr sz="1200" kern="1200">
+        <a:solidFill>
+          <a:schemeClr val="tx1"/>
+        </a:solidFill>
+        <a:latin typeface="+mn-lt"/>
+        <a:ea typeface="+mn-ea"/>
+        <a:cs typeface="+mn-cs"/>
+      </a:defRPr>
+    </a:lvl7pPr>
+    <a:lvl8pPr marL="3200400" algn="l" defTabSz="457200" rtl="0" eaLnBrk="1" latinLnBrk="0" hangingPunct="1">
+      <a:defRPr sz="1200" kern="1200">
+        <a:solidFill>
+          <a:schemeClr val="tx1"/>
+        </a:solidFill>
+        <a:latin typeface="+mn-lt"/>
+        <a:ea typeface="+mn-ea"/>
+        <a:cs typeface="+mn-cs"/>
+      </a:defRPr>
+    </a:lvl8pPr>
+    <a:lvl9pPr marL="3657600" algn="l" defTabSz="457200" rtl="0" eaLnBrk="1" latinLnBrk="0" hangingPunct="1">
+      <a:defRPr sz="1200" kern="1200">
+        <a:solidFill>
+          <a:schemeClr val="tx1"/>
+        </a:solidFill>
+        <a:latin typeface="+mn-lt"/>
+        <a:ea typeface="+mn-ea"/>
+        <a:cs typeface="+mn-cs"/>
+      </a:defRPr>
+    </a:lvl9pPr>
+  </p:notesStyle>
+</p:notesMaster>
+</file>
+
+<file path=ppt/notesSlides/notesSlide1.xml><?xml version="1.0" encoding="utf-8"?>
+<p:notes xmlns:a="http://schemas.openxmlformats.org/drawingml/2006/main" xmlns:p="http://schemas.openxmlformats.org/presentationml/2006/main" xmlns:r="http://schemas.openxmlformats.org/officeDocument/2006/relationships">
+  <p:cSld>
+    <p:spTree>
+      <p:nvGrpSpPr>
+        <p:cNvPr id="1" name=""/>
+        <p:cNvGrpSpPr/>
+        <p:nvPr/>
+      </p:nvGrpSpPr>
+      <p:grpSpPr>
+        <a:xfrm>
+          <a:off x="0" y="0"/>
+          <a:ext cx="0" cy="0"/>
+          <a:chOff x="0" y="0"/>
+          <a:chExt cx="0" cy="0"/>
+        </a:xfrm>
+      </p:grpSpPr>
+      <p:sp>
+        <p:nvSpPr>
+          <p:cNvPr id="2" name="Slide Image Placeholder 1"/>
+          <p:cNvSpPr>
+            <a:spLocks noGrp="1"/>
+          </p:cNvSpPr>
+          <p:nvPr>
+            <p:ph type="sldImg" idx="2"/>
+          </p:nvPr>
+        </p:nvSpPr>
+        <p:spPr/>
+      </p:sp>
+      <p:sp>
+        <p:nvSpPr>
+          <p:cNvPr id="3" name="Notes Placeholder 2"/>
+          <p:cNvSpPr>
+            <a:spLocks noGrp="1"/>
+          </p:cNvSpPr>
+          <p:nvPr>
+            <p:ph type="body" idx="3" sz="quarter"/>
+          </p:nvPr>
+        </p:nvSpPr>
+        <p:spPr/>
+        <p:txBody>
+          <a:bodyPr/>
+          <a:lstStyle/>
+          <a:p>
+            <a:r>
+              <a:t>안녕하십니까. PLM기술팀 김성훈입니다. 오늘은 우리 디지털 트윈(가상공장)을 한 단계 끌어올릴 Physical AI 과제를 제안드립니다. 6개월 안에 직접 만들어 보여드릴 수 있는 실증 과제입니다. (약 30초)</a:t>
+            </a:r>
+          </a:p>
+        </p:txBody>
+      </p:sp>
+      <p:sp>
+        <p:nvSpPr>
+          <p:cNvPr id="4" name="Slide Number Placeholder 3"/>
+          <p:cNvSpPr>
+            <a:spLocks noGrp="1"/>
+          </p:cNvSpPr>
+          <p:nvPr>
+            <p:ph type="sldNum" idx="5" sz="quarter"/>
+          </p:nvPr>
+        </p:nvSpPr>
+        <p:spPr/>
+      </p:sp>
+    </p:spTree>
+  </p:cSld>
+  <p:clrMapOvr>
+    <a:masterClrMapping/>
+  </p:clrMapOvr>
+</p:notes>
+</file>
+
+<file path=ppt/notesSlides/notesSlide2.xml><?xml version="1.0" encoding="utf-8"?>
+<p:notes xmlns:a="http://schemas.openxmlformats.org/drawingml/2006/main" xmlns:p="http://schemas.openxmlformats.org/presentationml/2006/main" xmlns:r="http://schemas.openxmlformats.org/officeDocument/2006/relationships">
+  <p:cSld>
+    <p:spTree>
+      <p:nvGrpSpPr>
+        <p:cNvPr id="1" name=""/>
+        <p:cNvGrpSpPr/>
+        <p:nvPr/>
+      </p:nvGrpSpPr>
+      <p:grpSpPr>
+        <a:xfrm>
+          <a:off x="0" y="0"/>
+          <a:ext cx="0" cy="0"/>
+          <a:chOff x="0" y="0"/>
+          <a:chExt cx="0" cy="0"/>
+        </a:xfrm>
+      </p:grpSpPr>
+      <p:sp>
+        <p:nvSpPr>
+          <p:cNvPr id="2" name="Slide Image Placeholder 1"/>
+          <p:cNvSpPr>
+            <a:spLocks noGrp="1"/>
+          </p:cNvSpPr>
+          <p:nvPr>
+            <p:ph type="sldImg" idx="2"/>
+          </p:nvPr>
+        </p:nvSpPr>
+        <p:spPr/>
+      </p:sp>
+      <p:sp>
+        <p:nvSpPr>
+          <p:cNvPr id="3" name="Notes Placeholder 2"/>
+          <p:cNvSpPr>
+            <a:spLocks noGrp="1"/>
+          </p:cNvSpPr>
+          <p:nvPr>
+            <p:ph type="body" idx="3" sz="quarter"/>
+          </p:nvPr>
+        </p:nvSpPr>
+        <p:spPr/>
+        <p:txBody>
+          <a:bodyPr/>
+          <a:lstStyle/>
+          <a:p>
+            <a:r>
+              <a:t>핵심은 이 한 문장입니다. '가상공장 안에서 조립 라인 이상을 스스로 감지하고, 어떻게 대응할지까지 결정하는 AI 에이전트를 직접 만든다.' 6개월 뒤 실제 동작을 시연하는 것이 목표입니다. (약 45초)</a:t>
+            </a:r>
+          </a:p>
+        </p:txBody>
+      </p:sp>
+      <p:sp>
+        <p:nvSpPr>
+          <p:cNvPr id="4" name="Slide Number Placeholder 3"/>
+          <p:cNvSpPr>
+            <a:spLocks noGrp="1"/>
+          </p:cNvSpPr>
+          <p:nvPr>
+            <p:ph type="sldNum" idx="5" sz="quarter"/>
+          </p:nvPr>
+        </p:nvSpPr>
+        <p:spPr/>
+      </p:sp>
+    </p:spTree>
+  </p:cSld>
+  <p:clrMapOvr>
+    <a:masterClrMapping/>
+  </p:clrMapOvr>
+</p:notes>
+</file>
+
+<file path=ppt/notesSlides/notesSlide3.xml><?xml version="1.0" encoding="utf-8"?>
+<p:notes xmlns:a="http://schemas.openxmlformats.org/drawingml/2006/main" xmlns:p="http://schemas.openxmlformats.org/presentationml/2006/main" xmlns:r="http://schemas.openxmlformats.org/officeDocument/2006/relationships">
+  <p:cSld>
+    <p:spTree>
+      <p:nvGrpSpPr>
+        <p:cNvPr id="1" name=""/>
+        <p:cNvGrpSpPr/>
+        <p:nvPr/>
+      </p:nvGrpSpPr>
+      <p:grpSpPr>
+        <a:xfrm>
+          <a:off x="0" y="0"/>
+          <a:ext cx="0" cy="0"/>
+          <a:chOff x="0" y="0"/>
+          <a:chExt cx="0" cy="0"/>
+        </a:xfrm>
+      </p:grpSpPr>
+      <p:sp>
+        <p:nvSpPr>
+          <p:cNvPr id="2" name="Slide Image Placeholder 1"/>
+          <p:cNvSpPr>
+            <a:spLocks noGrp="1"/>
+          </p:cNvSpPr>
+          <p:nvPr>
+            <p:ph type="sldImg" idx="2"/>
+          </p:nvPr>
+        </p:nvSpPr>
+        <p:spPr/>
+      </p:sp>
+      <p:sp>
+        <p:nvSpPr>
+          <p:cNvPr id="3" name="Notes Placeholder 2"/>
+          <p:cNvSpPr>
+            <a:spLocks noGrp="1"/>
+          </p:cNvSpPr>
+          <p:nvPr>
+            <p:ph type="body" idx="3" sz="quarter"/>
+          </p:nvPr>
+        </p:nvSpPr>
+        <p:spPr/>
+        <p:txBody>
+          <a:bodyPr/>
+          <a:lstStyle/>
+          <a:p>
+            <a:r>
+              <a:t>최근 제조업에서 보고·판단·행동하는 Physical AI 흐름이 커지고 있습니다. 우리는 이미 트윈이 있어 출발선이 앞섭니다. 다만 '보는 것'에 머물면 가치가 멈춥니다. 가장 위험한 건 관심만 있고 손대지 않는 것입니다. 작더라도 직접 만든 PoC가 가장 확실한 첫걸음입니다. (약 60초)</a:t>
+            </a:r>
+          </a:p>
+        </p:txBody>
+      </p:sp>
+      <p:sp>
+        <p:nvSpPr>
+          <p:cNvPr id="4" name="Slide Number Placeholder 3"/>
+          <p:cNvSpPr>
+            <a:spLocks noGrp="1"/>
+          </p:cNvSpPr>
+          <p:nvPr>
+            <p:ph type="sldNum" idx="5" sz="quarter"/>
+          </p:nvPr>
+        </p:nvSpPr>
+        <p:spPr/>
+      </p:sp>
+    </p:spTree>
+  </p:cSld>
+  <p:clrMapOvr>
+    <a:masterClrMapping/>
+  </p:clrMapOvr>
+</p:notes>
+</file>
+
+<file path=ppt/notesSlides/notesSlide4.xml><?xml version="1.0" encoding="utf-8"?>
+<p:notes xmlns:a="http://schemas.openxmlformats.org/drawingml/2006/main" xmlns:p="http://schemas.openxmlformats.org/presentationml/2006/main" xmlns:r="http://schemas.openxmlformats.org/officeDocument/2006/relationships">
+  <p:cSld>
+    <p:spTree>
+      <p:nvGrpSpPr>
+        <p:cNvPr id="1" name=""/>
+        <p:cNvGrpSpPr/>
+        <p:nvPr/>
+      </p:nvGrpSpPr>
+      <p:grpSpPr>
+        <a:xfrm>
+          <a:off x="0" y="0"/>
+          <a:ext cx="0" cy="0"/>
+          <a:chOff x="0" y="0"/>
+          <a:chExt cx="0" cy="0"/>
+        </a:xfrm>
+      </p:grpSpPr>
+      <p:sp>
+        <p:nvSpPr>
+          <p:cNvPr id="2" name="Slide Image Placeholder 1"/>
+          <p:cNvSpPr>
+            <a:spLocks noGrp="1"/>
+          </p:cNvSpPr>
+          <p:nvPr>
+            <p:ph type="sldImg" idx="2"/>
+          </p:nvPr>
+        </p:nvSpPr>
+        <p:spPr/>
+      </p:sp>
+      <p:sp>
+        <p:nvSpPr>
+          <p:cNvPr id="3" name="Notes Placeholder 2"/>
+          <p:cNvSpPr>
+            <a:spLocks noGrp="1"/>
+          </p:cNvSpPr>
+          <p:nvPr>
+            <p:ph type="body" idx="3" sz="quarter"/>
+          </p:nvPr>
+        </p:nvSpPr>
+        <p:spPr/>
+        <p:txBody>
+          <a:bodyPr/>
+          <a:lstStyle/>
+          <a:p>
+            <a:r>
+              <a:t>과제는 조립 라인 이상감지·대응 에이전트입니다. 인지(카메라 감시)→판단(이상 감지·분류)→행동(대응 선택) 3단계. 핵심은 '불량입니다'로 끝나는 검사기가 아니라, 무엇을 할지 스스로 정하는 에이전트라는 점입니다. (약 60초)</a:t>
+            </a:r>
+          </a:p>
+        </p:txBody>
+      </p:sp>
+      <p:sp>
+        <p:nvSpPr>
+          <p:cNvPr id="4" name="Slide Number Placeholder 3"/>
+          <p:cNvSpPr>
+            <a:spLocks noGrp="1"/>
+          </p:cNvSpPr>
+          <p:nvPr>
+            <p:ph type="sldNum" idx="5" sz="quarter"/>
+          </p:nvPr>
+        </p:nvSpPr>
+        <p:spPr/>
+      </p:sp>
+    </p:spTree>
+  </p:cSld>
+  <p:clrMapOvr>
+    <a:masterClrMapping/>
+  </p:clrMapOvr>
+</p:notes>
+</file>
+
+<file path=ppt/notesSlides/notesSlide5.xml><?xml version="1.0" encoding="utf-8"?>
+<p:notes xmlns:a="http://schemas.openxmlformats.org/drawingml/2006/main" xmlns:p="http://schemas.openxmlformats.org/presentationml/2006/main" xmlns:r="http://schemas.openxmlformats.org/officeDocument/2006/relationships">
+  <p:cSld>
+    <p:spTree>
+      <p:nvGrpSpPr>
+        <p:cNvPr id="1" name=""/>
+        <p:cNvGrpSpPr/>
+        <p:nvPr/>
+      </p:nvGrpSpPr>
+      <p:grpSpPr>
+        <a:xfrm>
+          <a:off x="0" y="0"/>
+          <a:ext cx="0" cy="0"/>
+          <a:chOff x="0" y="0"/>
+          <a:chExt cx="0" cy="0"/>
+        </a:xfrm>
+      </p:grpSpPr>
+      <p:sp>
+        <p:nvSpPr>
+          <p:cNvPr id="2" name="Slide Image Placeholder 1"/>
+          <p:cNvSpPr>
+            <a:spLocks noGrp="1"/>
+          </p:cNvSpPr>
+          <p:nvPr>
+            <p:ph type="sldImg" idx="2"/>
+          </p:nvPr>
+        </p:nvSpPr>
+        <p:spPr/>
+      </p:sp>
+      <p:sp>
+        <p:nvSpPr>
+          <p:cNvPr id="3" name="Notes Placeholder 2"/>
+          <p:cNvSpPr>
+            <a:spLocks noGrp="1"/>
+          </p:cNvSpPr>
+          <p:nvPr>
+            <p:ph type="body" idx="3" sz="quarter"/>
+          </p:nvPr>
+        </p:nvSpPr>
+        <p:spPr/>
+        <p:txBody>
+          <a:bodyPr/>
+          <a:lstStyle/>
+          <a:p>
+            <a:r>
+              <a:t>왼쪽부터 인지·판단·행동으로 흐르고, 행동은 경고/정지/호출로 갈라집니다. 위쪽 초록 박스가 핵심 — 합성 데이터로 AI를 가르치는 부분이며 다음 장에서 설명합니다. (약 45초)</a:t>
+            </a:r>
+          </a:p>
+        </p:txBody>
+      </p:sp>
+      <p:sp>
+        <p:nvSpPr>
+          <p:cNvPr id="4" name="Slide Number Placeholder 3"/>
+          <p:cNvSpPr>
+            <a:spLocks noGrp="1"/>
+          </p:cNvSpPr>
+          <p:nvPr>
+            <p:ph type="sldNum" idx="5" sz="quarter"/>
+          </p:nvPr>
+        </p:nvSpPr>
+        <p:spPr/>
+      </p:sp>
+    </p:spTree>
+  </p:cSld>
+  <p:clrMapOvr>
+    <a:masterClrMapping/>
+  </p:clrMapOvr>
+</p:notes>
+</file>
+
+<file path=ppt/notesSlides/notesSlide6.xml><?xml version="1.0" encoding="utf-8"?>
+<p:notes xmlns:a="http://schemas.openxmlformats.org/drawingml/2006/main" xmlns:p="http://schemas.openxmlformats.org/presentationml/2006/main" xmlns:r="http://schemas.openxmlformats.org/officeDocument/2006/relationships">
+  <p:cSld>
+    <p:spTree>
+      <p:nvGrpSpPr>
+        <p:cNvPr id="1" name=""/>
+        <p:cNvGrpSpPr/>
+        <p:nvPr/>
+      </p:nvGrpSpPr>
+      <p:grpSpPr>
+        <a:xfrm>
+          <a:off x="0" y="0"/>
+          <a:ext cx="0" cy="0"/>
+          <a:chOff x="0" y="0"/>
+          <a:chExt cx="0" cy="0"/>
+        </a:xfrm>
+      </p:grpSpPr>
+      <p:sp>
+        <p:nvSpPr>
+          <p:cNvPr id="2" name="Slide Image Placeholder 1"/>
+          <p:cNvSpPr>
+            <a:spLocks noGrp="1"/>
+          </p:cNvSpPr>
+          <p:nvPr>
+            <p:ph type="sldImg" idx="2"/>
+          </p:nvPr>
+        </p:nvSpPr>
+        <p:spPr/>
+      </p:sp>
+      <p:sp>
+        <p:nvSpPr>
+          <p:cNvPr id="3" name="Notes Placeholder 2"/>
+          <p:cNvSpPr>
+            <a:spLocks noGrp="1"/>
+          </p:cNvSpPr>
+          <p:nvPr>
+            <p:ph type="body" idx="3" sz="quarter"/>
+          </p:nvPr>
+        </p:nvSpPr>
+        <p:spPr/>
+        <p:txBody>
+          <a:bodyPr/>
+          <a:lstStyle/>
+          <a:p>
+            <a:r>
+              <a:t>검사 AI의 최대 벽은 '이상 데이터가 없다'입니다. 우리는 트윈으로 이상을 무한히 합성해 이 벽을 넘습니다. 그러면 트윈이 'AI 학습 데이터 공장'이 되고 트윈팀 가치도 함께 오릅니다. NVIDIA Physical AI의 정석 전략입니다. (이 슬라이드가 보고의 심장) (약 60초)</a:t>
+            </a:r>
+          </a:p>
+        </p:txBody>
+      </p:sp>
+      <p:sp>
+        <p:nvSpPr>
+          <p:cNvPr id="4" name="Slide Number Placeholder 3"/>
+          <p:cNvSpPr>
+            <a:spLocks noGrp="1"/>
+          </p:cNvSpPr>
+          <p:nvPr>
+            <p:ph type="sldNum" idx="5" sz="quarter"/>
+          </p:nvPr>
+        </p:nvSpPr>
+        <p:spPr/>
+      </p:sp>
+    </p:spTree>
+  </p:cSld>
+  <p:clrMapOvr>
+    <a:masterClrMapping/>
+  </p:clrMapOvr>
+</p:notes>
+</file>
+
+<file path=ppt/notesSlides/notesSlide7.xml><?xml version="1.0" encoding="utf-8"?>
+<p:notes xmlns:a="http://schemas.openxmlformats.org/drawingml/2006/main" xmlns:p="http://schemas.openxmlformats.org/presentationml/2006/main" xmlns:r="http://schemas.openxmlformats.org/officeDocument/2006/relationships">
+  <p:cSld>
+    <p:spTree>
+      <p:nvGrpSpPr>
+        <p:cNvPr id="1" name=""/>
+        <p:cNvGrpSpPr/>
+        <p:nvPr/>
+      </p:nvGrpSpPr>
+      <p:grpSpPr>
+        <a:xfrm>
+          <a:off x="0" y="0"/>
+          <a:ext cx="0" cy="0"/>
+          <a:chOff x="0" y="0"/>
+          <a:chExt cx="0" cy="0"/>
+        </a:xfrm>
+      </p:grpSpPr>
+      <p:sp>
+        <p:nvSpPr>
+          <p:cNvPr id="2" name="Slide Image Placeholder 1"/>
+          <p:cNvSpPr>
+            <a:spLocks noGrp="1"/>
+          </p:cNvSpPr>
+          <p:nvPr>
+            <p:ph type="sldImg" idx="2"/>
+          </p:nvPr>
+        </p:nvSpPr>
+        <p:spPr/>
+      </p:sp>
+      <p:sp>
+        <p:nvSpPr>
+          <p:cNvPr id="3" name="Notes Placeholder 2"/>
+          <p:cNvSpPr>
+            <a:spLocks noGrp="1"/>
+          </p:cNvSpPr>
+          <p:nvPr>
+            <p:ph type="body" idx="3" sz="quarter"/>
+          </p:nvPr>
+        </p:nvSpPr>
+        <p:spPr/>
+        <p:txBody>
+          <a:bodyPr/>
+          <a:lstStyle/>
+          <a:p>
+            <a:r>
+              <a:t>단기: 직접 만든 Physical AI 실증 사례 확보. 중기: 실라인 연결 시 품질 이상 자동 감지·대응으로 확장. 전략: '트윈을 가진 회사'에서 '트윈 위에서 지능이 도는 회사'로. (약 40초)</a:t>
+            </a:r>
+          </a:p>
+        </p:txBody>
+      </p:sp>
+      <p:sp>
+        <p:nvSpPr>
+          <p:cNvPr id="4" name="Slide Number Placeholder 3"/>
+          <p:cNvSpPr>
+            <a:spLocks noGrp="1"/>
+          </p:cNvSpPr>
+          <p:nvPr>
+            <p:ph type="sldNum" idx="5" sz="quarter"/>
+          </p:nvPr>
+        </p:nvSpPr>
+        <p:spPr/>
+      </p:sp>
+    </p:spTree>
+  </p:cSld>
+  <p:clrMapOvr>
+    <a:masterClrMapping/>
+  </p:clrMapOvr>
+</p:notes>
+</file>
+
+<file path=ppt/notesSlides/notesSlide8.xml><?xml version="1.0" encoding="utf-8"?>
+<p:notes xmlns:a="http://schemas.openxmlformats.org/drawingml/2006/main" xmlns:p="http://schemas.openxmlformats.org/presentationml/2006/main" xmlns:r="http://schemas.openxmlformats.org/officeDocument/2006/relationships">
+  <p:cSld>
+    <p:spTree>
+      <p:nvGrpSpPr>
+        <p:cNvPr id="1" name=""/>
+        <p:cNvGrpSpPr/>
+        <p:nvPr/>
+      </p:nvGrpSpPr>
+      <p:grpSpPr>
+        <a:xfrm>
+          <a:off x="0" y="0"/>
+          <a:ext cx="0" cy="0"/>
+          <a:chOff x="0" y="0"/>
+          <a:chExt cx="0" cy="0"/>
+        </a:xfrm>
+      </p:grpSpPr>
+      <p:sp>
+        <p:nvSpPr>
+          <p:cNvPr id="2" name="Slide Image Placeholder 1"/>
+          <p:cNvSpPr>
+            <a:spLocks noGrp="1"/>
+          </p:cNvSpPr>
+          <p:nvPr>
+            <p:ph type="sldImg" idx="2"/>
+          </p:nvPr>
+        </p:nvSpPr>
+        <p:spPr/>
+      </p:sp>
+      <p:sp>
+        <p:nvSpPr>
+          <p:cNvPr id="3" name="Notes Placeholder 2"/>
+          <p:cNvSpPr>
+            <a:spLocks noGrp="1"/>
+          </p:cNvSpPr>
+          <p:nvPr>
+            <p:ph type="body" idx="3" sz="quarter"/>
+          </p:nvPr>
+        </p:nvSpPr>
+        <p:spPr/>
+        <p:txBody>
+          <a:bodyPr/>
+          <a:lstStyle/>
+          <a:p>
+            <a:r>
+              <a:t>6개월 계획. 3개월 차에 이상을 잡는 AI(첫 성과), 4개월 차에 감지→대응 에이전트 완성. 6개월을 다 기다리지 않고 3개월부터 중간 결과를 계속 보여드립니다. (약 50초)</a:t>
+            </a:r>
+          </a:p>
+        </p:txBody>
+      </p:sp>
+      <p:sp>
+        <p:nvSpPr>
+          <p:cNvPr id="4" name="Slide Number Placeholder 3"/>
+          <p:cNvSpPr>
+            <a:spLocks noGrp="1"/>
+          </p:cNvSpPr>
+          <p:nvPr>
+            <p:ph type="sldNum" idx="5" sz="quarter"/>
+          </p:nvPr>
+        </p:nvSpPr>
+        <p:spPr/>
+      </p:sp>
+    </p:spTree>
+  </p:cSld>
+  <p:clrMapOvr>
+    <a:masterClrMapping/>
+  </p:clrMapOvr>
+</p:notes>
+</file>
+
+<file path=ppt/notesSlides/notesSlide9.xml><?xml version="1.0" encoding="utf-8"?>
+<p:notes xmlns:a="http://schemas.openxmlformats.org/drawingml/2006/main" xmlns:p="http://schemas.openxmlformats.org/presentationml/2006/main" xmlns:r="http://schemas.openxmlformats.org/officeDocument/2006/relationships">
+  <p:cSld>
+    <p:spTree>
+      <p:nvGrpSpPr>
+        <p:cNvPr id="1" name=""/>
+        <p:cNvGrpSpPr/>
+        <p:nvPr/>
+      </p:nvGrpSpPr>
+      <p:grpSpPr>
+        <a:xfrm>
+          <a:off x="0" y="0"/>
+          <a:ext cx="0" cy="0"/>
+          <a:chOff x="0" y="0"/>
+          <a:chExt cx="0" cy="0"/>
+        </a:xfrm>
+      </p:grpSpPr>
+      <p:sp>
+        <p:nvSpPr>
+          <p:cNvPr id="2" name="Slide Image Placeholder 1"/>
+          <p:cNvSpPr>
+            <a:spLocks noGrp="1"/>
+          </p:cNvSpPr>
+          <p:nvPr>
+            <p:ph type="sldImg" idx="2"/>
+          </p:nvPr>
+        </p:nvSpPr>
+        <p:spPr/>
+      </p:sp>
+      <p:sp>
+        <p:nvSpPr>
+          <p:cNvPr id="3" name="Notes Placeholder 2"/>
+          <p:cNvSpPr>
+            <a:spLocks noGrp="1"/>
+          </p:cNvSpPr>
+          <p:nvPr>
+            <p:ph type="body" idx="3" sz="quarter"/>
+          </p:nvPr>
+        </p:nvSpPr>
+        <p:spPr/>
+        <p:txBody>
+          <a:bodyPr/>
+          <a:lstStyle/>
+          <a:p>
+            <a:r>
+              <a:t>요청 셋: 트윈 자산 공유 협조, RTX 워크스테이션 1대, 6개월 추진 승인. 한 문장 정리 — '이상 데이터가 없어 막히는 문제를 우리 트윈으로 만들어 AI가 스스로 판단·대응하게 한다.' 감사합니다. (약 40초)</a:t>
+            </a:r>
+          </a:p>
+        </p:txBody>
+      </p:sp>
+      <p:sp>
+        <p:nvSpPr>
+          <p:cNvPr id="4" name="Slide Number Placeholder 3"/>
+          <p:cNvSpPr>
+            <a:spLocks noGrp="1"/>
+          </p:cNvSpPr>
+          <p:nvPr>
+            <p:ph type="sldNum" idx="5" sz="quarter"/>
+          </p:nvPr>
+        </p:nvSpPr>
+        <p:spPr/>
+      </p:sp>
+    </p:spTree>
+  </p:cSld>
+  <p:clrMapOvr>
+    <a:masterClrMapping/>
+  </p:clrMapOvr>
+</p:notes>
 </file>
 
 <file path=ppt/slideLayouts/slideLayout1.xml><?xml version="1.0" encoding="utf-8"?>
@@ -6697,4 +7677,324 @@
   </a:objectDefaults>
   <a:extraClrSchemeLst/>
 </a:theme>
+</file>
+
+<file path=ppt/theme/theme2.xml><?xml version="1.0" encoding="utf-8"?>
+<a:theme xmlns:a="http://schemas.openxmlformats.org/drawingml/2006/main" name="Office Theme">
+  <a:themeElements>
+    <a:clrScheme name="Office">
+      <a:dk1>
+        <a:sysClr val="windowText" lastClr="000000"/>
+      </a:dk1>
+      <a:lt1>
+        <a:sysClr val="window" lastClr="FFFFFF"/>
+      </a:lt1>
+      <a:dk2>
+        <a:srgbClr val="1F497D"/>
+      </a:dk2>
+      <a:lt2>
+        <a:srgbClr val="EEECE1"/>
+      </a:lt2>
+      <a:accent1>
+        <a:srgbClr val="4F81BD"/>
+      </a:accent1>
+      <a:accent2>
+        <a:srgbClr val="C0504D"/>
+      </a:accent2>
+      <a:accent3>
+        <a:srgbClr val="9BBB59"/>
+      </a:accent3>
+      <a:accent4>
+        <a:srgbClr val="8064A2"/>
+      </a:accent4>
+      <a:accent5>
+        <a:srgbClr val="4BACC6"/>
+      </a:accent5>
+      <a:accent6>
+        <a:srgbClr val="F79646"/>
+      </a:accent6>
+      <a:hlink>
+        <a:srgbClr val="0000FF"/>
+      </a:hlink>
+      <a:folHlink>
+        <a:srgbClr val="800080"/>
+      </a:folHlink>
+    </a:clrScheme>
+    <a:fontScheme name="Office">
+      <a:majorFont>
+        <a:latin typeface="Calibri"/>
+        <a:ea typeface=""/>
+        <a:cs typeface=""/>
+        <a:font script="Jpan" typeface="ＭＳ Ｐゴシック"/>
+        <a:font script="Hang" typeface="맑은 고딕"/>
+        <a:font script="Hans" typeface="宋体"/>
+        <a:font script="Hant" typeface="新細明體"/>
+        <a:font script="Arab" typeface="Times New Roman"/>
+        <a:font script="Hebr" typeface="Times New Roman"/>
+        <a:font script="Thai" typeface="Angsana New"/>
+        <a:font script="Ethi" typeface="Nyala"/>
+        <a:font script="Beng" typeface="Vrinda"/>
+        <a:font script="Gujr" typeface="Shruti"/>
+        <a:font script="Khmr" typeface="MoolBoran"/>
+        <a:font script="Knda" typeface="Tunga"/>
+        <a:font script="Guru" typeface="Raavi"/>
+        <a:font script="Cans" typeface="Euphemia"/>
+        <a:font script="Cher" typeface="Plantagenet Cherokee"/>
+        <a:font script="Yiii" typeface="Microsoft Yi Baiti"/>
+        <a:font script="Tibt" typeface="Microsoft Himalaya"/>
+        <a:font script="Thaa" typeface="MV Boli"/>
+        <a:font script="Deva" typeface="Mangal"/>
+        <a:font script="Telu" typeface="Gautami"/>
+        <a:font script="Taml" typeface="Latha"/>
+        <a:font script="Syrc" typeface="Estrangelo Edessa"/>
+        <a:font script="Orya" typeface="Kalinga"/>
+        <a:font script="Mlym" typeface="Kartika"/>
+        <a:font script="Laoo" typeface="DokChampa"/>
+        <a:font script="Sinh" typeface="Iskoola Pota"/>
+        <a:font script="Mong" typeface="Mongolian Baiti"/>
+        <a:font script="Viet" typeface="Times New Roman"/>
+        <a:font script="Uigh" typeface="Microsoft Uighur"/>
+        <a:font script="Geor" typeface="Sylfaen"/>
+      </a:majorFont>
+      <a:minorFont>
+        <a:latin typeface="Calibri"/>
+        <a:ea typeface=""/>
+        <a:cs typeface=""/>
+        <a:font script="Jpan" typeface="ＭＳ Ｐゴシック"/>
+        <a:font script="Hang" typeface="맑은 고딕"/>
+        <a:font script="Hans" typeface="宋体"/>
+        <a:font script="Hant" typeface="新細明體"/>
+        <a:font script="Arab" typeface="Arial"/>
+        <a:font script="Hebr" typeface="Arial"/>
+        <a:font script="Thai" typeface="Cordia New"/>
+        <a:font script="Ethi" typeface="Nyala"/>
+        <a:font script="Beng" typeface="Vrinda"/>
+        <a:font script="Gujr" typeface="Shruti"/>
+        <a:font script="Khmr" typeface="DaunPenh"/>
+        <a:font script="Knda" typeface="Tunga"/>
+        <a:font script="Guru" typeface="Raavi"/>
+        <a:font script="Cans" typeface="Euphemia"/>
+        <a:font script="Cher" typeface="Plantagenet Cherokee"/>
+        <a:font script="Yiii" typeface="Microsoft Yi Baiti"/>
+        <a:font script="Tibt" typeface="Microsoft Himalaya"/>
+        <a:font script="Thaa" typeface="MV Boli"/>
+        <a:font script="Deva" typeface="Mangal"/>
+        <a:font script="Telu" typeface="Gautami"/>
+        <a:font script="Taml" typeface="Latha"/>
+        <a:font script="Syrc" typeface="Estrangelo Edessa"/>
+        <a:font script="Orya" typeface="Kalinga"/>
+        <a:font script="Mlym" typeface="Kartika"/>
+        <a:font script="Laoo" typeface="DokChampa"/>
+        <a:font script="Sinh" typeface="Iskoola Pota"/>
+        <a:font script="Mong" typeface="Mongolian Baiti"/>
+        <a:font script="Viet" typeface="Arial"/>
+        <a:font script="Uigh" typeface="Microsoft Uighur"/>
+        <a:font script="Geor" typeface="Sylfaen"/>
+      </a:minorFont>
+    </a:fontScheme>
+    <a:fmtScheme name="Office">
+      <a:fillStyleLst>
+        <a:solidFill>
+          <a:schemeClr val="phClr"/>
+        </a:solidFill>
+        <a:gradFill rotWithShape="1">
+          <a:gsLst>
+            <a:gs pos="0">
+              <a:schemeClr val="phClr">
+                <a:tint val="50000"/>
+                <a:satMod val="300000"/>
+              </a:schemeClr>
+            </a:gs>
+            <a:gs pos="35000">
+              <a:schemeClr val="phClr">
+                <a:tint val="37000"/>
+                <a:satMod val="300000"/>
+              </a:schemeClr>
+            </a:gs>
+            <a:gs pos="100000">
+              <a:schemeClr val="phClr">
+                <a:tint val="15000"/>
+                <a:satMod val="350000"/>
+              </a:schemeClr>
+            </a:gs>
+          </a:gsLst>
+          <a:lin ang="16200000" scaled="1"/>
+        </a:gradFill>
+        <a:gradFill rotWithShape="1">
+          <a:gsLst>
+            <a:gs pos="0">
+              <a:schemeClr val="phClr">
+                <a:tint val="100000"/>
+                <a:shade val="100000"/>
+                <a:satMod val="130000"/>
+              </a:schemeClr>
+            </a:gs>
+            <a:gs pos="100000">
+              <a:schemeClr val="phClr">
+                <a:tint val="50000"/>
+                <a:shade val="100000"/>
+                <a:satMod val="350000"/>
+              </a:schemeClr>
+            </a:gs>
+          </a:gsLst>
+          <a:lin ang="16200000" scaled="0"/>
+        </a:gradFill>
+      </a:fillStyleLst>
+      <a:lnStyleLst>
+        <a:ln w="9525" cap="flat" cmpd="sng" algn="ctr">
+          <a:solidFill>
+            <a:schemeClr val="phClr">
+              <a:shade val="95000"/>
+              <a:satMod val="105000"/>
+            </a:schemeClr>
+          </a:solidFill>
+          <a:prstDash val="solid"/>
+        </a:ln>
+        <a:ln w="25400" cap="flat" cmpd="sng" algn="ctr">
+          <a:solidFill>
+            <a:schemeClr val="phClr"/>
+          </a:solidFill>
+          <a:prstDash val="solid"/>
+        </a:ln>
+        <a:ln w="38100" cap="flat" cmpd="sng" algn="ctr">
+          <a:solidFill>
+            <a:schemeClr val="phClr"/>
+          </a:solidFill>
+          <a:prstDash val="solid"/>
+        </a:ln>
+      </a:lnStyleLst>
+      <a:effectStyleLst>
+        <a:effectStyle>
+          <a:effectLst>
+            <a:outerShdw blurRad="40000" dist="20000" dir="5400000" rotWithShape="0">
+              <a:srgbClr val="000000">
+                <a:alpha val="38000"/>
+              </a:srgbClr>
+            </a:outerShdw>
+          </a:effectLst>
+        </a:effectStyle>
+        <a:effectStyle>
+          <a:effectLst>
+            <a:outerShdw blurRad="40000" dist="23000" dir="5400000" rotWithShape="0">
+              <a:srgbClr val="000000">
+                <a:alpha val="35000"/>
+              </a:srgbClr>
+            </a:outerShdw>
+          </a:effectLst>
+        </a:effectStyle>
+        <a:effectStyle>
+          <a:effectLst>
+            <a:outerShdw blurRad="40000" dist="23000" dir="5400000" rotWithShape="0">
+              <a:srgbClr val="000000">
+                <a:alpha val="35000"/>
+              </a:srgbClr>
+            </a:outerShdw>
+          </a:effectLst>
+          <a:scene3d>
+            <a:camera prst="orthographicFront">
+              <a:rot lat="0" lon="0" rev="0"/>
+            </a:camera>
+            <a:lightRig rig="threePt" dir="t">
+              <a:rot lat="0" lon="0" rev="1200000"/>
+            </a:lightRig>
+          </a:scene3d>
+          <a:sp3d>
+            <a:bevelT w="63500" h="25400"/>
+          </a:sp3d>
+        </a:effectStyle>
+      </a:effectStyleLst>
+      <a:bgFillStyleLst>
+        <a:solidFill>
+          <a:schemeClr val="phClr"/>
+        </a:solidFill>
+        <a:gradFill rotWithShape="1">
+          <a:gsLst>
+            <a:gs pos="0">
+              <a:schemeClr val="phClr">
+                <a:tint val="40000"/>
+                <a:satMod val="350000"/>
+              </a:schemeClr>
+            </a:gs>
+            <a:gs pos="40000">
+              <a:schemeClr val="phClr">
+                <a:tint val="45000"/>
+                <a:shade val="99000"/>
+                <a:satMod val="350000"/>
+              </a:schemeClr>
+            </a:gs>
+            <a:gs pos="100000">
+              <a:schemeClr val="phClr">
+                <a:shade val="20000"/>
+                <a:satMod val="255000"/>
+              </a:schemeClr>
+            </a:gs>
+          </a:gsLst>
+          <a:path path="circle">
+            <a:fillToRect l="50000" t="-80000" r="50000" b="180000"/>
+          </a:path>
+        </a:gradFill>
+        <a:gradFill rotWithShape="1">
+          <a:gsLst>
+            <a:gs pos="0">
+              <a:schemeClr val="phClr">
+                <a:tint val="80000"/>
+                <a:satMod val="300000"/>
+              </a:schemeClr>
+            </a:gs>
+            <a:gs pos="100000">
+              <a:schemeClr val="phClr">
+                <a:shade val="30000"/>
+                <a:satMod val="200000"/>
+              </a:schemeClr>
+            </a:gs>
+          </a:gsLst>
+          <a:path path="circle">
+            <a:fillToRect l="50000" t="50000" r="50000" b="50000"/>
+          </a:path>
+        </a:gradFill>
+      </a:bgFillStyleLst>
+    </a:fmtScheme>
+  </a:themeElements>
+  <a:objectDefaults>
+    <a:spDef>
+      <a:spPr/>
+      <a:bodyPr/>
+      <a:lstStyle/>
+      <a:style>
+        <a:lnRef idx="1">
+          <a:schemeClr val="accent1"/>
+        </a:lnRef>
+        <a:fillRef idx="3">
+          <a:schemeClr val="accent1"/>
+        </a:fillRef>
+        <a:effectRef idx="2">
+          <a:schemeClr val="accent1"/>
+        </a:effectRef>
+        <a:fontRef idx="minor">
+          <a:schemeClr val="lt1"/>
+        </a:fontRef>
+      </a:style>
+    </a:spDef>
+    <a:lnDef>
+      <a:spPr/>
+      <a:bodyPr/>
+      <a:lstStyle/>
+      <a:style>
+        <a:lnRef idx="2">
+          <a:schemeClr val="accent1"/>
+        </a:lnRef>
+        <a:fillRef idx="0">
+          <a:schemeClr val="accent1"/>
+        </a:fillRef>
+        <a:effectRef idx="1">
+          <a:schemeClr val="accent1"/>
+        </a:effectRef>
+        <a:fontRef idx="minor">
+          <a:schemeClr val="tx1"/>
+        </a:fontRef>
+      </a:style>
+    </a:lnDef>
+  </a:objectDefaults>
+  <a:extraClrSchemeLst/>
+</a:theme>
 </file>
</xml_diff>